<commit_message>
Presentación contada como historia: problema, lo que hicimos, hallazgos, por qué importa
- Cuatro actos con el lenguaje del equipo: «En el papel, Bogotá mejora. La
  gente no lo siente», «Y mucho delito ni siquiera se denuncia», «El mapa de
  las denuncias no es el mapa del miedo», y luego lo que hicimos, lo que
  encontramos y por qué importa (dónde actuar, qué arreglar, cómo saber si
  funciona).
- Los hechos violentos (violencia intrafamiliar y delitos sexuales) con
  tarjeta propia; la cifra oculta pasa al acto del problema y la prueba
  estadística a su propia lámina («No es casualidad»).
- Al pie de cada lámina se ve en qué acto va la historia; un acto por
  presentador; guion reescrito en tono conversacional.
- El modo captura del respaldo desactiva animaciones para que el PDF salga
  completo.

Co-Authored-By: Claude Opus 5.5 <noreply@anthropic.com>
</commit_message>
<xml_diff>
--- a/docs/pitch/Pitch_El_miedo_que_no_baja_The_data_squad.pptx
+++ b/docs/pitch/Pitch_El_miedo_que_no_baja_The_data_squad.pptx
@@ -16,6 +16,7 @@
     <p:sldId id="264" r:id="rId16"/>
     <p:sldId id="265" r:id="rId17"/>
     <p:sldId id="266" r:id="rId18"/>
+    <p:sldId id="267" r:id="rId19"/>
   </p:sldIdLst>
   <p:sldSz cx="12191695" cy="6858000" type="screen4x3"/>
   <p:notesSz cx="6858000" cy="9144000"/>
@@ -512,7 +513,7 @@
           <a:lstStyle/>
           <a:p>
             <a:r>
-              <a:t>Brandow (0:00-0:15): Somos The data squad. Venimos a explicar una paradoja de Bogotá: el delito registrado baja, pero el miedo no. ¿Por qué pasa, y dónde debe actuar primero el Distrito?</a:t>
+              <a:t>Brandow (0:00-0:10): Somos The data squad. Les vamos a contar algo que encontramos en los datos de Bogotá y que no cuadra.</a:t>
             </a:r>
           </a:p>
         </p:txBody>
@@ -582,7 +583,7 @@
           <a:lstStyle/>
           <a:p>
             <a:r>
-              <a:t>Brandow (4:40-5:15): Proponemos un indicador para toda la ciudad: el Índice de Brecha, con fuentes que ya existen, cada semestre y por UPL. (→) Y cuatro decisiones: medir con victimización; priorizar entornos con la regla del índice, que hoy señala a Usme, Ciudad Bolívar, Bosa, Kennedy y San Cristóbal; medir la autonomía de las mujeres; y abrir los datos para evaluar.</a:t>
+              <a:t>Samuel (4:00-4:35): Con las mujeres es más fuerte. Denuncian menos que los hombres. (→) Pero tienen mucho más miedo al acoso y dejan de salir de noche. (→) Comparando mujeres y hombres de igual edad, estrato y victimización: +18 puntos de temor al acoso. El miedo les cuesta libertad.</a:t>
             </a:r>
           </a:p>
         </p:txBody>
@@ -652,7 +653,77 @@
           <a:lstStyle/>
           <a:p>
             <a:r>
-              <a:t>Brandow (5:15-5:25): Bogotá ya produce los datos para cerrar esta brecha. Hay que leerlos juntos. Gracias.</a:t>
+              <a:t>Brandow (4:35-5:15): ¿Por qué importa? Porque le decimos al Distrito dónde actuar primero: estas cinco localidades. (→) Qué arreglar: lo que la gente ve en su barrio, parques, convivencia y alumbrado, pensando en las mujeres. (→) Y cómo saber si de verdad la gente se siente más segura, no solo si bajan las denuncias: este índice cada semestre. Todo con datos que el Distrito ya tiene.</a:t>
+            </a:r>
+          </a:p>
+        </p:txBody>
+      </p:sp>
+      <p:sp>
+        <p:nvSpPr>
+          <p:cNvPr id="4" name="Slide Number Placeholder 3"/>
+          <p:cNvSpPr>
+            <a:spLocks noGrp="1"/>
+          </p:cNvSpPr>
+          <p:nvPr>
+            <p:ph type="sldNum" idx="5" sz="quarter"/>
+          </p:nvPr>
+        </p:nvSpPr>
+        <p:spPr/>
+      </p:sp>
+    </p:spTree>
+  </p:cSld>
+  <p:clrMapOvr>
+    <a:masterClrMapping/>
+  </p:clrMapOvr>
+</p:notes>
+</file>
+
+<file path=ppt/notesSlides/notesSlide12.xml><?xml version="1.0" encoding="utf-8"?>
+<p:notes xmlns:a="http://schemas.openxmlformats.org/drawingml/2006/main" xmlns:p="http://schemas.openxmlformats.org/presentationml/2006/main" xmlns:r="http://schemas.openxmlformats.org/officeDocument/2006/relationships">
+  <p:cSld>
+    <p:spTree>
+      <p:nvGrpSpPr>
+        <p:cNvPr id="1" name=""/>
+        <p:cNvGrpSpPr/>
+        <p:nvPr/>
+      </p:nvGrpSpPr>
+      <p:grpSpPr>
+        <a:xfrm>
+          <a:off x="0" y="0"/>
+          <a:ext cx="0" cy="0"/>
+          <a:chOff x="0" y="0"/>
+          <a:chExt cx="0" cy="0"/>
+        </a:xfrm>
+      </p:grpSpPr>
+      <p:sp>
+        <p:nvSpPr>
+          <p:cNvPr id="2" name="Slide Image Placeholder 1"/>
+          <p:cNvSpPr>
+            <a:spLocks noGrp="1"/>
+          </p:cNvSpPr>
+          <p:nvPr>
+            <p:ph type="sldImg" idx="2"/>
+          </p:nvPr>
+        </p:nvSpPr>
+        <p:spPr/>
+      </p:sp>
+      <p:sp>
+        <p:nvSpPr>
+          <p:cNvPr id="3" name="Notes Placeholder 2"/>
+          <p:cNvSpPr>
+            <a:spLocks noGrp="1"/>
+          </p:cNvSpPr>
+          <p:nvPr>
+            <p:ph type="body" idx="3" sz="quarter"/>
+          </p:nvPr>
+        </p:nvSpPr>
+        <p:spPr/>
+        <p:txBody>
+          <a:bodyPr/>
+          <a:lstStyle/>
+          <a:p>
+            <a:r>
+              <a:t>Brandow (5:15-5:25): Bogotá ya tiene los datos para cerrar esta brecha. Solo hay que leerlos juntos. Gracias.</a:t>
             </a:r>
           </a:p>
         </p:txBody>
@@ -722,7 +793,7 @@
           <a:lstStyle/>
           <a:p>
             <a:r>
-              <a:t>Brandow (0:15-0:45): (Aparece la línea azul) El hurto a personas registrado cayó 65 % entre 2019 y 2026. (→) Pero no todo baja: la violencia intrafamiliar y los delitos sexuales suben, y pasan sobre todo en la casa. (→) Y el 74 % de los adultos siente insegura la ciudad. Lo que se cuenta baja; lo que se siente, no.</a:t>
+              <a:t>Brandow (0:10-0:45): Resulta que estuvimos revisando los datos de la Secretaría de Seguridad y el hurto viene bajando muchísimo: −65 % desde 2019. (→) Pero hay hechos violentos que van al revés: la violencia intrafamiliar y los delitos sexuales subieron cerca de 45 %. (→) Y cuando lo cruzamos con las encuestas, 3 de cada 4 personas dicen que Bogotá es insegura. O sea: en el papel la ciudad mejora, pero la gente no lo siente.</a:t>
             </a:r>
           </a:p>
         </p:txBody>
@@ -792,7 +863,7 @@
           <a:lstStyle/>
           <a:p>
             <a:r>
-              <a:t>Brandow (0:45-1:15): Pregúntenle al público antes de mostrar: si el miedo siguiera al delito, ¿dónde esperarían más miedo? (→) Donde más se registra: esta diagonal. (→) Pero no: Usme y Ciudad Bolívar registran poco y tienen el miedo más alto; Teusaquillo y Los Mártires registran mucho y tienen menos. La correlación es −0,25: ninguna. El registro no dice dónde está el miedo.</a:t>
+              <a:t>Brandow (0:45-1:15): Y nos dimos cuenta de que mucho delito ni siquiera llega a las cifras. Hagan la cuenta con nosotros (señalen los tres pasos): el 24,6 % de los adultos dice haber sido víctima en el último año, unos 1,5 millones de personas; la Secretaría registró unos 275 mil delitos. Por cada 100 víctimas, solo 18 quedan en el registro. (Cambien el selector a Bosa: 9.)</a:t>
             </a:r>
           </a:p>
         </p:txBody>
@@ -862,7 +933,7 @@
           <a:lstStyle/>
           <a:p>
             <a:r>
-              <a:t>Rafael (1:15-1:40): ¿Cómo lo sabemos? Unimos siete fuentes públicas: dos encuestas para lo que se siente, la Secretaría de Seguridad para lo que se registra y cuatro de contexto. (→) Cada fuente escribe la localidad distinto: todo se lleva al código oficial. (→) Y siempre comparamos por habitante: en casos gana Suba porque es enorme; por habitante, el centro.</a:t>
+              <a:t>Brandow (1:15-1:40): Pregúntenle al público: si el miedo siguiera al delito registrado, ¿dónde esperarían más miedo? (→) Donde más se registra: esta diagonal. (→) Pero no: Usme y Ciudad Bolívar registran poco y tienen el miedo más alto. El Distrito está tomando decisiones con un mapa al que le falta más de la mitad.</a:t>
             </a:r>
           </a:p>
         </p:txBody>
@@ -932,7 +1003,7 @@
           <a:lstStyle/>
           <a:p>
             <a:r>
-              <a:t>Rafael (1:40-2:25): Para medir la brecha con una sola cifra construimos el Índice de Brecha. Primero el miedo en una regla común: desviaciones frente al promedio de la ciudad. (→) Luego el registro en la misma regla. (→) Y restamos: Usme tiene +1,40 de miedo y −1,27 de registro, brecha de +2,67. (→) Como toda estimación tiene margen de error, la repetimos 1.000 veces: Usme y Ciudad Bolívar quedan en el top 5 en todas, Bosa en el 99,5 %.</a:t>
+              <a:t>Rafael (1:40-2:00): ¿Qué hicimos? Juntamos todo: lo que la gente siente, de dos encuestas; lo que el Estado registra, de la Secretaría de Seguridad; y población, parques y alumbrado. (→) Cada fuente escribe la localidad distinto, así que todo lo llevamos al mismo código. (→) Y comparamos por habitante, para que Suba no gane solo por ser grande.</a:t>
             </a:r>
           </a:p>
         </p:txBody>
@@ -1002,7 +1073,7 @@
           <a:lstStyle/>
           <a:p>
             <a:r>
-              <a:t>Rafael (2:25-3:05): Primer hallazgo. Hagamos la cuenta en tres pasos (señálenlos): el 24,6 % de los adultos dice haber sido víctima de un delito en el último año, unos 1,5 millones de personas; la Secretaría registró unos 275 mil delitos. Por cada 100 víctimas, el registro tiene 18 delitos. (Cambien el selector a Bosa: 9 de cada 100.) (→) Y donde hay más miedo que registro, más delito se queda sin registrar: correlación de 0,72. (→) ¿Casualidad? Probamos siete relaciones y solo esta sobrevive a la corrección por pruebas múltiples. El miedo de la periferia no es exagerado: es delito que no llega a las cifras.</a:t>
+              <a:t>Rafael (2:00-2:40): Con eso armamos un índice que dice en qué localidades hay más miedo del que muestran las cifras. Pasamos el miedo y el delito a la misma regla, cuánto se alejan del promedio de la ciudad, (→ →) y los restamos: Usme tiene +1,40 de miedo y −1,27 de registro, brecha de +2,67. (→) Las que más brecha tienen: Usme, Ciudad Bolívar, Bosa, Kennedy y San Cristóbal. Lo repetimos 1.000 veces y casi siempre son las mismas.</a:t>
             </a:r>
           </a:p>
         </p:txBody>
@@ -1072,7 +1143,7 @@
           <a:lstStyle/>
           <a:p>
             <a:r>
-              <a:t>Samuel (3:05-3:45): ¿Qué hace que alguien sienta insegura su zona? Comparemos personas iguales en todo menos en una cosa. Esta vecina parte de 39 %. (→ muevan el deslizador de hurtos de punta a punta) Del menor al mayor hurto registrado: casi nada. Los homicidios sí pesan algo. (→ activen «atracos en el parque» y suban los conflictos) Ver atracos en el parque: +14 puntos. Conflictos con vecinos: hasta +16. El barrio se siente por lo que pasa en él.</a:t>
+              <a:t>Rafael (2:40-3:05): ¿Y eso es real? Donde el índice marca más miedo, más delito se queda sin denunciar: correlación de 0,72. (→) Probamos siete relaciones distintas y esta es la única que pasa la corrección por azar. O sea: el miedo de la periferia no es exagerado, es delito que no llega a las cifras.</a:t>
             </a:r>
           </a:p>
         </p:txBody>
@@ -1142,7 +1213,7 @@
           <a:lstStyle/>
           <a:p>
             <a:r>
-              <a:t>Samuel (3:45-4:05): ¿Y si fue suerte? Repetimos el análisis 300 veces sorteando localidades. (Los puntos caen) Los atracos en el parque nunca tocan el cero. (→) El hurto registrado cae a los dos lados del cero: no se distingue de nada.</a:t>
+              <a:t>Samuel (3:05-3:45): ¿Qué es lo que de verdad le da miedo a la gente? Comparamos personas iguales en todo menos en una cosa. Esta vecina parte de 39 %. (→ muevan el hurto de punta a punta) Las estadísticas de hurto de su localidad: casi nada. (→ activen atracos y suban los conflictos) Ver atracos en el parque: +14 puntos. Peleas entre vecinos: hasta +16. Lo que da miedo es lo que se ve en el barrio.</a:t>
             </a:r>
           </a:p>
         </p:txBody>
@@ -1212,7 +1283,7 @@
           <a:lstStyle/>
           <a:p>
             <a:r>
-              <a:t>Samuel (4:05-4:40): Tercer hallazgo. Las mujeres dicen haber sido víctimas menos que los hombres. (→) Pero temen más el acoso y evitan más salir de noche. (→) Comparando iguales, con la misma edad, estrato y victimización, ser mujer suma 18 puntos de temor al acoso sexual. El costo del miedo se paga en autonomía.</a:t>
+              <a:t>Samuel (3:45-4:00): Y no fue suerte: repetimos el análisis 300 veces sorteando las localidades. (Los puntos caen) Los atracos nunca bajan de cero. (→) El hurto registrado cae a los dos lados: no explica nada.</a:t>
             </a:r>
           </a:p>
         </p:txBody>
@@ -4262,6 +4333,48 @@
       <p:grpSpPr/>
       <p:pic>
         <p:nvPicPr>
+          <p:cNvPr id="2" name="Picture 1" descr="genero_pptx.png"/>
+          <p:cNvPicPr>
+            <a:picLocks noChangeAspect="1"/>
+          </p:cNvPicPr>
+          <p:nvPr/>
+        </p:nvPicPr>
+        <p:blipFill>
+          <a:blip r:embed="rId2"/>
+          <a:stretch>
+            <a:fillRect/>
+          </a:stretch>
+        </p:blipFill>
+        <p:spPr>
+          <a:xfrm>
+            <a:off x="0" y="0"/>
+            <a:ext cx="12191695" cy="6858000"/>
+          </a:xfrm>
+          <a:prstGeom prst="rect">
+            <a:avLst/>
+          </a:prstGeom>
+        </p:spPr>
+      </p:pic>
+    </p:spTree>
+  </p:cSld>
+  <p:clrMapOvr>
+    <a:masterClrMapping/>
+  </p:clrMapOvr>
+</p:sld>
+</file>
+
+<file path=ppt/slides/slide11.xml><?xml version="1.0" encoding="utf-8"?>
+<p:sld xmlns:a="http://schemas.openxmlformats.org/drawingml/2006/main" xmlns:p="http://schemas.openxmlformats.org/presentationml/2006/main" xmlns:r="http://schemas.openxmlformats.org/officeDocument/2006/relationships">
+  <p:cSld>
+    <p:spTree>
+      <p:nvGrpSpPr>
+        <p:cNvPr id="1" name=""/>
+        <p:cNvGrpSpPr/>
+        <p:nvPr/>
+      </p:nvGrpSpPr>
+      <p:grpSpPr/>
+      <p:pic>
+        <p:nvPicPr>
           <p:cNvPr id="2" name="Picture 1" descr="propuesta_pptx.png"/>
           <p:cNvPicPr>
             <a:picLocks noChangeAspect="1"/>
@@ -4292,7 +4405,7 @@
 </p:sld>
 </file>
 
-<file path=ppt/slides/slide11.xml><?xml version="1.0" encoding="utf-8"?>
+<file path=ppt/slides/slide12.xml><?xml version="1.0" encoding="utf-8"?>
 <p:sld xmlns:a="http://schemas.openxmlformats.org/drawingml/2006/main" xmlns:p="http://schemas.openxmlformats.org/presentationml/2006/main" xmlns:r="http://schemas.openxmlformats.org/officeDocument/2006/relationships">
   <p:cSld>
     <p:spTree>
@@ -4388,7 +4501,7 @@
       <p:grpSpPr/>
       <p:pic>
         <p:nvPicPr>
-          <p:cNvPr id="2" name="Picture 1" descr="termometros_pptx.png"/>
+          <p:cNvPr id="2" name="Picture 1" descr="cifra-oculta_pptx.png"/>
           <p:cNvPicPr>
             <a:picLocks noChangeAspect="1"/>
           </p:cNvPicPr>
@@ -4430,7 +4543,7 @@
       <p:grpSpPr/>
       <p:pic>
         <p:nvPicPr>
-          <p:cNvPr id="2" name="Picture 1" descr="datos_pptx.png"/>
+          <p:cNvPr id="2" name="Picture 1" descr="termometros_pptx.png"/>
           <p:cNvPicPr>
             <a:picLocks noChangeAspect="1"/>
           </p:cNvPicPr>
@@ -4472,7 +4585,7 @@
       <p:grpSpPr/>
       <p:pic>
         <p:nvPicPr>
-          <p:cNvPr id="2" name="Picture 1" descr="indice_pptx.png"/>
+          <p:cNvPr id="2" name="Picture 1" descr="datos_pptx.png"/>
           <p:cNvPicPr>
             <a:picLocks noChangeAspect="1"/>
           </p:cNvPicPr>
@@ -4514,7 +4627,7 @@
       <p:grpSpPr/>
       <p:pic>
         <p:nvPicPr>
-          <p:cNvPr id="2" name="Picture 1" descr="cifra-oculta_pptx.png"/>
+          <p:cNvPr id="2" name="Picture 1" descr="indice_pptx.png"/>
           <p:cNvPicPr>
             <a:picLocks noChangeAspect="1"/>
           </p:cNvPicPr>
@@ -4556,7 +4669,7 @@
       <p:grpSpPr/>
       <p:pic>
         <p:nvPicPr>
-          <p:cNvPr id="2" name="Picture 1" descr="vecinos_pptx.png"/>
+          <p:cNvPr id="2" name="Picture 1" descr="prueba_pptx.png"/>
           <p:cNvPicPr>
             <a:picLocks noChangeAspect="1"/>
           </p:cNvPicPr>
@@ -4598,7 +4711,7 @@
       <p:grpSpPr/>
       <p:pic>
         <p:nvPicPr>
-          <p:cNvPr id="2" name="Picture 1" descr="repeticiones_pptx.png"/>
+          <p:cNvPr id="2" name="Picture 1" descr="vecinos_pptx.png"/>
           <p:cNvPicPr>
             <a:picLocks noChangeAspect="1"/>
           </p:cNvPicPr>
@@ -4640,7 +4753,7 @@
       <p:grpSpPr/>
       <p:pic>
         <p:nvPicPr>
-          <p:cNvPr id="2" name="Picture 1" descr="genero_pptx.png"/>
+          <p:cNvPr id="2" name="Picture 1" descr="repeticiones_pptx.png"/>
           <p:cNvPicPr>
             <a:picLocks noChangeAspect="1"/>
           </p:cNvPicPr>

</xml_diff>

<commit_message>
Corrige H2: la correlación entre el Índice de Brecha y la cifra oculta es mecánica
Los dos índices usan el delito registrado (uno lo resta, el otro lo divide).
Con Spearman parcial controlando el registro, ρ pasa de 0,72 a −0,02 (p = 0,93);
la prueba directa, miedo frente a cifra oculta, da 0,16 (p = 0,51). H2 queda
como no sostenida: el marcador es 2 de 8.

- src: spearman_parcial, prueba directa y tabla validacion_parcial.csv
- README, nota técnica, formulario, Excel, notebook y visor con la lectura corregida
- AUC: "ordenan bien 72 de cada 100 parejas; con calificaciones, 85"
- Informe técnico completo (15 páginas) en docs/ y en Entregables
- Power BI: filas de la correlación parcial y de víctimas frente a registro
- Pitch regenerado; signo menos tipográfico en las cifras del visor

Co-Authored-By: Claude Opus 5.5 <noreply@anthropic.com>
</commit_message>
<xml_diff>
--- a/docs/pitch/Pitch_El_miedo_que_no_baja_The_data_squad.pptx
+++ b/docs/pitch/Pitch_El_miedo_que_no_baja_The_data_squad.pptx
@@ -725,7 +725,7 @@
           <a:lstStyle/>
           <a:p>
             <a:r>
-              <a:t>Samuel (4:20-4:40): Probamos ocho hipótesis, incluidas las que cualquiera daría por ciertas. (→) Cinco no se sostienen: la serie de hurto no era comparable, el delito registrado no explica el miedo, peor alumbrado o peores vías no traen más hurto, y más luz o internet no se asocian con menos violencia contra ellas. Tres sí: el entorno del barrio, la cifra oculta y el miedo de las mujeres. (→) Un nulo también es evidencia: evita gastar en lo que no mueve la aguja.</a:t>
+              <a:t>Samuel (4:20-4:40): Probamos ocho hipótesis, incluidas las que cualquiera daría por ciertas. (→) Seis no se sostienen: la serie de hurto no era comparable, el delito registrado no explica el miedo, peor alumbrado o peores vías no traen más hurto, más luz o internet no se asocian con menos violencia contra ellas, y la relación entre miedo y cifra oculta era mecánica. Dos sí: el entorno del barrio y el miedo de las mujeres. (→) Un nulo también es evidencia: evita gastar en lo que no mueve la aguja.</a:t>
             </a:r>
           </a:p>
         </p:txBody>
@@ -1285,7 +1285,7 @@
           <a:lstStyle/>
           <a:p>
             <a:r>
-              <a:t>Rafael (2:30-2:55): Segundo modelo: entrenamos tres modelos para predecir quién siente insegura su zona y los probamos con personas que no vieron. Aciertan hasta 85 de cada 100. (→) Lo que más explica es lo que pasa en el barrio: atracos, conflictos, parques. (→) Y la prueba clave: el delito registrado no agrega nada a saber en qué localidad vive la persona: 0,722 frente a 0,726. El miedo sigue a lo que la gente vive, no a la estadística.</a:t>
+              <a:t>Rafael (2:30-2:55): Segundo modelo: entrenamos tres modelos para predecir quién siente insegura su zona y los probamos con personas que no vieron. Con hechos y contexto ordenan bien 72 de cada 100 parejas; con las calificaciones del barrio, 85. (→) Lo que más explica es lo que pasa en el barrio: atracos, conflictos, parques. (→) Y la prueba clave: el delito registrado no agrega nada a saber en qué localidad vive la persona: 0,722 frente a 0,726. El miedo sigue a lo que la gente vive, no a la estadística.</a:t>
             </a:r>
           </a:p>
         </p:txBody>

</xml_diff>